<commit_message>
updated .docx & .pptx
</commit_message>
<xml_diff>
--- a/conference/resources/Conference.pptx
+++ b/conference/resources/Conference.pptx
@@ -252,7 +252,7 @@
           <a:p>
             <a:fld id="{3DE9BC87-07BA-0548-91E7-15A1E0ED04A0}" type="datetimeFigureOut">
               <a:rPr lang="ru-GB" smtClean="0"/>
-              <a:t>04/17/2026</a:t>
+              <a:t>20/04/2026</a:t>
             </a:fld>
             <a:endParaRPr lang="ru-GB"/>
           </a:p>
@@ -3331,7 +3331,7 @@
           <a:p>
             <a:fld id="{2970958D-8FD3-704D-8A72-D3764ABAF413}" type="datetimeFigureOut">
               <a:rPr lang="ru-GB" smtClean="0"/>
-              <a:t>04/17/2026</a:t>
+              <a:t>20/04/2026</a:t>
             </a:fld>
             <a:endParaRPr lang="ru-GB"/>
           </a:p>
@@ -3531,7 +3531,7 @@
           <a:p>
             <a:fld id="{2970958D-8FD3-704D-8A72-D3764ABAF413}" type="datetimeFigureOut">
               <a:rPr lang="ru-GB" smtClean="0"/>
-              <a:t>04/17/2026</a:t>
+              <a:t>20/04/2026</a:t>
             </a:fld>
             <a:endParaRPr lang="ru-GB"/>
           </a:p>
@@ -3741,7 +3741,7 @@
           <a:p>
             <a:fld id="{2970958D-8FD3-704D-8A72-D3764ABAF413}" type="datetimeFigureOut">
               <a:rPr lang="ru-GB" smtClean="0"/>
-              <a:t>04/17/2026</a:t>
+              <a:t>20/04/2026</a:t>
             </a:fld>
             <a:endParaRPr lang="ru-GB"/>
           </a:p>
@@ -3941,7 +3941,7 @@
           <a:p>
             <a:fld id="{2970958D-8FD3-704D-8A72-D3764ABAF413}" type="datetimeFigureOut">
               <a:rPr lang="ru-GB" smtClean="0"/>
-              <a:t>04/17/2026</a:t>
+              <a:t>20/04/2026</a:t>
             </a:fld>
             <a:endParaRPr lang="ru-GB"/>
           </a:p>
@@ -4217,7 +4217,7 @@
           <a:p>
             <a:fld id="{2970958D-8FD3-704D-8A72-D3764ABAF413}" type="datetimeFigureOut">
               <a:rPr lang="ru-GB" smtClean="0"/>
-              <a:t>04/17/2026</a:t>
+              <a:t>20/04/2026</a:t>
             </a:fld>
             <a:endParaRPr lang="ru-GB"/>
           </a:p>
@@ -4485,7 +4485,7 @@
           <a:p>
             <a:fld id="{2970958D-8FD3-704D-8A72-D3764ABAF413}" type="datetimeFigureOut">
               <a:rPr lang="ru-GB" smtClean="0"/>
-              <a:t>04/17/2026</a:t>
+              <a:t>20/04/2026</a:t>
             </a:fld>
             <a:endParaRPr lang="ru-GB"/>
           </a:p>
@@ -4900,7 +4900,7 @@
           <a:p>
             <a:fld id="{2970958D-8FD3-704D-8A72-D3764ABAF413}" type="datetimeFigureOut">
               <a:rPr lang="ru-GB" smtClean="0"/>
-              <a:t>04/17/2026</a:t>
+              <a:t>20/04/2026</a:t>
             </a:fld>
             <a:endParaRPr lang="ru-GB"/>
           </a:p>
@@ -5042,7 +5042,7 @@
           <a:p>
             <a:fld id="{2970958D-8FD3-704D-8A72-D3764ABAF413}" type="datetimeFigureOut">
               <a:rPr lang="ru-GB" smtClean="0"/>
-              <a:t>04/17/2026</a:t>
+              <a:t>20/04/2026</a:t>
             </a:fld>
             <a:endParaRPr lang="ru-GB"/>
           </a:p>
@@ -5155,7 +5155,7 @@
           <a:p>
             <a:fld id="{2970958D-8FD3-704D-8A72-D3764ABAF413}" type="datetimeFigureOut">
               <a:rPr lang="ru-GB" smtClean="0"/>
-              <a:t>04/17/2026</a:t>
+              <a:t>20/04/2026</a:t>
             </a:fld>
             <a:endParaRPr lang="ru-GB"/>
           </a:p>
@@ -5468,7 +5468,7 @@
           <a:p>
             <a:fld id="{2970958D-8FD3-704D-8A72-D3764ABAF413}" type="datetimeFigureOut">
               <a:rPr lang="ru-GB" smtClean="0"/>
-              <a:t>04/17/2026</a:t>
+              <a:t>20/04/2026</a:t>
             </a:fld>
             <a:endParaRPr lang="ru-GB"/>
           </a:p>
@@ -5757,7 +5757,7 @@
           <a:p>
             <a:fld id="{2970958D-8FD3-704D-8A72-D3764ABAF413}" type="datetimeFigureOut">
               <a:rPr lang="ru-GB" smtClean="0"/>
-              <a:t>04/17/2026</a:t>
+              <a:t>20/04/2026</a:t>
             </a:fld>
             <a:endParaRPr lang="ru-GB"/>
           </a:p>
@@ -6000,7 +6000,7 @@
           <a:p>
             <a:fld id="{2970958D-8FD3-704D-8A72-D3764ABAF413}" type="datetimeFigureOut">
               <a:rPr lang="ru-GB" smtClean="0"/>
-              <a:t>04/17/2026</a:t>
+              <a:t>20/04/2026</a:t>
             </a:fld>
             <a:endParaRPr lang="ru-GB"/>
           </a:p>
@@ -6901,7 +6901,7 @@
         </p:nvSpPr>
         <p:spPr>
           <a:xfrm>
-            <a:off x="5378860" y="2412411"/>
+            <a:off x="5360551" y="2412410"/>
             <a:ext cx="1899761" cy="908729"/>
           </a:xfrm>
           <a:prstGeom prst="rect">
@@ -6971,7 +6971,7 @@
         </p:nvSpPr>
         <p:spPr>
           <a:xfrm>
-            <a:off x="5360555" y="3484162"/>
+            <a:off x="5360553" y="3484162"/>
             <a:ext cx="1899761" cy="908729"/>
           </a:xfrm>
           <a:prstGeom prst="rect">
@@ -8156,7 +8156,7 @@
         </p:nvSpPr>
         <p:spPr>
           <a:xfrm>
-            <a:off x="5378860" y="2412411"/>
+            <a:off x="5360555" y="2412410"/>
             <a:ext cx="1899761" cy="908729"/>
           </a:xfrm>
           <a:prstGeom prst="rect">
@@ -9426,7 +9426,7 @@
         </p:nvSpPr>
         <p:spPr>
           <a:xfrm>
-            <a:off x="5378860" y="2412411"/>
+            <a:off x="5360551" y="2412410"/>
             <a:ext cx="1899761" cy="908729"/>
           </a:xfrm>
           <a:prstGeom prst="rect">
@@ -10681,7 +10681,7 @@
         </p:nvSpPr>
         <p:spPr>
           <a:xfrm>
-            <a:off x="5378860" y="2412411"/>
+            <a:off x="5360555" y="2412410"/>
             <a:ext cx="1899761" cy="908729"/>
           </a:xfrm>
           <a:prstGeom prst="rect">
@@ -11949,7 +11949,7 @@
         </p:nvSpPr>
         <p:spPr>
           <a:xfrm>
-            <a:off x="5378860" y="2412411"/>
+            <a:off x="5360555" y="2412410"/>
             <a:ext cx="1899761" cy="908729"/>
           </a:xfrm>
           <a:prstGeom prst="rect">
@@ -13207,7 +13207,7 @@
         </p:nvSpPr>
         <p:spPr>
           <a:xfrm>
-            <a:off x="5378860" y="2412411"/>
+            <a:off x="5360554" y="2412411"/>
             <a:ext cx="1899761" cy="908729"/>
           </a:xfrm>
           <a:prstGeom prst="rect">
@@ -14517,7 +14517,7 @@
         </p:nvSpPr>
         <p:spPr>
           <a:xfrm>
-            <a:off x="5378860" y="2412411"/>
+            <a:off x="5360554" y="2412411"/>
             <a:ext cx="1899761" cy="908729"/>
           </a:xfrm>
           <a:prstGeom prst="rect">
@@ -25923,10 +25923,10 @@
           <p:nvPr/>
         </p:nvPicPr>
         <p:blipFill>
-          <a:blip r:embed="rId4">
+          <a:blip>
             <a:extLst>
               <a:ext uri="{96DAC541-7B7A-43D3-8B79-37D633B846F1}">
-                <asvg:svgBlip xmlns:asvg="http://schemas.microsoft.com/office/drawing/2016/SVG/main" r:embed="rId5"/>
+                <asvg:svgBlip xmlns:asvg="http://schemas.microsoft.com/office/drawing/2016/SVG/main" r:embed="rId4"/>
               </a:ext>
             </a:extLst>
           </a:blip>
@@ -25959,10 +25959,10 @@
           <p:nvPr/>
         </p:nvPicPr>
         <p:blipFill>
-          <a:blip r:embed="rId6">
+          <a:blip>
             <a:extLst>
               <a:ext uri="{96DAC541-7B7A-43D3-8B79-37D633B846F1}">
-                <asvg:svgBlip xmlns:asvg="http://schemas.microsoft.com/office/drawing/2016/SVG/main" r:embed="rId7"/>
+                <asvg:svgBlip xmlns:asvg="http://schemas.microsoft.com/office/drawing/2016/SVG/main" r:embed="rId5"/>
               </a:ext>
             </a:extLst>
           </a:blip>
@@ -25995,10 +25995,10 @@
           <p:nvPr/>
         </p:nvPicPr>
         <p:blipFill>
-          <a:blip r:embed="rId8">
+          <a:blip>
             <a:extLst>
               <a:ext uri="{96DAC541-7B7A-43D3-8B79-37D633B846F1}">
-                <asvg:svgBlip xmlns:asvg="http://schemas.microsoft.com/office/drawing/2016/SVG/main" r:embed="rId9"/>
+                <asvg:svgBlip xmlns:asvg="http://schemas.microsoft.com/office/drawing/2016/SVG/main" r:embed="rId6"/>
               </a:ext>
             </a:extLst>
           </a:blip>
@@ -26138,7 +26138,7 @@
         </p:nvSpPr>
         <p:spPr>
           <a:xfrm>
-            <a:off x="9838227" y="4417891"/>
+            <a:off x="9843838" y="4531345"/>
             <a:ext cx="715260" cy="369332"/>
           </a:xfrm>
           <a:prstGeom prst="rect">
@@ -26205,10 +26205,10 @@
           <p:nvPr/>
         </p:nvPicPr>
         <p:blipFill>
-          <a:blip r:embed="rId3">
+          <a:blip>
             <a:extLst>
               <a:ext uri="{96DAC541-7B7A-43D3-8B79-37D633B846F1}">
-                <asvg:svgBlip xmlns:asvg="http://schemas.microsoft.com/office/drawing/2016/SVG/main" r:embed="rId4"/>
+                <asvg:svgBlip xmlns:asvg="http://schemas.microsoft.com/office/drawing/2016/SVG/main" r:embed="rId3"/>
               </a:ext>
             </a:extLst>
           </a:blip>
@@ -26271,10 +26271,10 @@
           <p:nvPr/>
         </p:nvPicPr>
         <p:blipFill>
-          <a:blip r:embed="rId2">
+          <a:blip>
             <a:extLst>
               <a:ext uri="{96DAC541-7B7A-43D3-8B79-37D633B846F1}">
-                <asvg:svgBlip xmlns:asvg="http://schemas.microsoft.com/office/drawing/2016/SVG/main" r:embed="rId3"/>
+                <asvg:svgBlip xmlns:asvg="http://schemas.microsoft.com/office/drawing/2016/SVG/main" r:embed="rId2"/>
               </a:ext>
             </a:extLst>
           </a:blip>
@@ -26421,10 +26421,10 @@
           <p:nvPr/>
         </p:nvPicPr>
         <p:blipFill>
-          <a:blip r:embed="rId2">
+          <a:blip>
             <a:extLst>
               <a:ext uri="{96DAC541-7B7A-43D3-8B79-37D633B846F1}">
-                <asvg:svgBlip xmlns:asvg="http://schemas.microsoft.com/office/drawing/2016/SVG/main" r:embed="rId3"/>
+                <asvg:svgBlip xmlns:asvg="http://schemas.microsoft.com/office/drawing/2016/SVG/main" r:embed="rId2"/>
               </a:ext>
             </a:extLst>
           </a:blip>
@@ -26571,10 +26571,10 @@
           <p:nvPr/>
         </p:nvPicPr>
         <p:blipFill>
-          <a:blip r:embed="rId2">
+          <a:blip>
             <a:extLst>
               <a:ext uri="{96DAC541-7B7A-43D3-8B79-37D633B846F1}">
-                <asvg:svgBlip xmlns:asvg="http://schemas.microsoft.com/office/drawing/2016/SVG/main" r:embed="rId3"/>
+                <asvg:svgBlip xmlns:asvg="http://schemas.microsoft.com/office/drawing/2016/SVG/main" r:embed="rId2"/>
               </a:ext>
             </a:extLst>
           </a:blip>
@@ -26721,10 +26721,10 @@
           <p:nvPr/>
         </p:nvPicPr>
         <p:blipFill>
-          <a:blip r:embed="rId2">
+          <a:blip>
             <a:extLst>
               <a:ext uri="{96DAC541-7B7A-43D3-8B79-37D633B846F1}">
-                <asvg:svgBlip xmlns:asvg="http://schemas.microsoft.com/office/drawing/2016/SVG/main" r:embed="rId3"/>
+                <asvg:svgBlip xmlns:asvg="http://schemas.microsoft.com/office/drawing/2016/SVG/main" r:embed="rId2"/>
               </a:ext>
             </a:extLst>
           </a:blip>
@@ -26871,10 +26871,10 @@
           <p:nvPr/>
         </p:nvPicPr>
         <p:blipFill>
-          <a:blip r:embed="rId2">
+          <a:blip>
             <a:extLst>
               <a:ext uri="{96DAC541-7B7A-43D3-8B79-37D633B846F1}">
-                <asvg:svgBlip xmlns:asvg="http://schemas.microsoft.com/office/drawing/2016/SVG/main" r:embed="rId3"/>
+                <asvg:svgBlip xmlns:asvg="http://schemas.microsoft.com/office/drawing/2016/SVG/main" r:embed="rId2"/>
               </a:ext>
             </a:extLst>
           </a:blip>
@@ -27021,10 +27021,10 @@
           <p:nvPr/>
         </p:nvPicPr>
         <p:blipFill>
-          <a:blip r:embed="rId2">
+          <a:blip>
             <a:extLst>
               <a:ext uri="{96DAC541-7B7A-43D3-8B79-37D633B846F1}">
-                <asvg:svgBlip xmlns:asvg="http://schemas.microsoft.com/office/drawing/2016/SVG/main" r:embed="rId3"/>
+                <asvg:svgBlip xmlns:asvg="http://schemas.microsoft.com/office/drawing/2016/SVG/main" r:embed="rId2"/>
               </a:ext>
             </a:extLst>
           </a:blip>
@@ -27171,10 +27171,10 @@
           <p:nvPr/>
         </p:nvPicPr>
         <p:blipFill>
-          <a:blip r:embed="rId2">
+          <a:blip>
             <a:extLst>
               <a:ext uri="{96DAC541-7B7A-43D3-8B79-37D633B846F1}">
-                <asvg:svgBlip xmlns:asvg="http://schemas.microsoft.com/office/drawing/2016/SVG/main" r:embed="rId3"/>
+                <asvg:svgBlip xmlns:asvg="http://schemas.microsoft.com/office/drawing/2016/SVG/main" r:embed="rId2"/>
               </a:ext>
             </a:extLst>
           </a:blip>
@@ -27364,10 +27364,10 @@
           <p:nvPr/>
         </p:nvPicPr>
         <p:blipFill>
-          <a:blip r:embed="rId2">
+          <a:blip>
             <a:extLst>
               <a:ext uri="{96DAC541-7B7A-43D3-8B79-37D633B846F1}">
-                <asvg:svgBlip xmlns:asvg="http://schemas.microsoft.com/office/drawing/2016/SVG/main" r:embed="rId3"/>
+                <asvg:svgBlip xmlns:asvg="http://schemas.microsoft.com/office/drawing/2016/SVG/main" r:embed="rId2"/>
               </a:ext>
             </a:extLst>
           </a:blip>
@@ -27557,10 +27557,10 @@
           <p:nvPr/>
         </p:nvPicPr>
         <p:blipFill>
-          <a:blip r:embed="rId2">
+          <a:blip>
             <a:extLst>
               <a:ext uri="{96DAC541-7B7A-43D3-8B79-37D633B846F1}">
-                <asvg:svgBlip xmlns:asvg="http://schemas.microsoft.com/office/drawing/2016/SVG/main" r:embed="rId3"/>
+                <asvg:svgBlip xmlns:asvg="http://schemas.microsoft.com/office/drawing/2016/SVG/main" r:embed="rId2"/>
               </a:ext>
             </a:extLst>
           </a:blip>
@@ -27910,10 +27910,10 @@
           <p:nvPr/>
         </p:nvPicPr>
         <p:blipFill>
-          <a:blip r:embed="rId3">
+          <a:blip>
             <a:extLst>
               <a:ext uri="{96DAC541-7B7A-43D3-8B79-37D633B846F1}">
-                <asvg:svgBlip xmlns:asvg="http://schemas.microsoft.com/office/drawing/2016/SVG/main" r:embed="rId4"/>
+                <asvg:svgBlip xmlns:asvg="http://schemas.microsoft.com/office/drawing/2016/SVG/main" r:embed="rId3"/>
               </a:ext>
             </a:extLst>
           </a:blip>
@@ -28012,10 +28012,10 @@
           <p:nvPr/>
         </p:nvPicPr>
         <p:blipFill>
-          <a:blip r:embed="rId2">
+          <a:blip>
             <a:extLst>
               <a:ext uri="{96DAC541-7B7A-43D3-8B79-37D633B846F1}">
-                <asvg:svgBlip xmlns:asvg="http://schemas.microsoft.com/office/drawing/2016/SVG/main" r:embed="rId3"/>
+                <asvg:svgBlip xmlns:asvg="http://schemas.microsoft.com/office/drawing/2016/SVG/main" r:embed="rId2"/>
               </a:ext>
             </a:extLst>
           </a:blip>
@@ -28078,10 +28078,10 @@
           <p:nvPr/>
         </p:nvPicPr>
         <p:blipFill>
-          <a:blip r:embed="rId3">
+          <a:blip>
             <a:extLst>
               <a:ext uri="{96DAC541-7B7A-43D3-8B79-37D633B846F1}">
-                <asvg:svgBlip xmlns:asvg="http://schemas.microsoft.com/office/drawing/2016/SVG/main" r:embed="rId4"/>
+                <asvg:svgBlip xmlns:asvg="http://schemas.microsoft.com/office/drawing/2016/SVG/main" r:embed="rId3"/>
               </a:ext>
             </a:extLst>
           </a:blip>
@@ -28180,10 +28180,10 @@
           <p:nvPr/>
         </p:nvPicPr>
         <p:blipFill>
-          <a:blip r:embed="rId3">
+          <a:blip>
             <a:extLst>
               <a:ext uri="{96DAC541-7B7A-43D3-8B79-37D633B846F1}">
-                <asvg:svgBlip xmlns:asvg="http://schemas.microsoft.com/office/drawing/2016/SVG/main" r:embed="rId4"/>
+                <asvg:svgBlip xmlns:asvg="http://schemas.microsoft.com/office/drawing/2016/SVG/main" r:embed="rId3"/>
               </a:ext>
             </a:extLst>
           </a:blip>
@@ -28840,10 +28840,10 @@
           <p:nvPr/>
         </p:nvPicPr>
         <p:blipFill>
-          <a:blip r:embed="rId3">
+          <a:blip>
             <a:extLst>
               <a:ext uri="{96DAC541-7B7A-43D3-8B79-37D633B846F1}">
-                <asvg:svgBlip xmlns:asvg="http://schemas.microsoft.com/office/drawing/2016/SVG/main" r:embed="rId4"/>
+                <asvg:svgBlip xmlns:asvg="http://schemas.microsoft.com/office/drawing/2016/SVG/main" r:embed="rId3"/>
               </a:ext>
             </a:extLst>
           </a:blip>
@@ -29398,10 +29398,10 @@
           <p:nvPr/>
         </p:nvPicPr>
         <p:blipFill>
-          <a:blip r:embed="rId3">
+          <a:blip>
             <a:extLst>
               <a:ext uri="{96DAC541-7B7A-43D3-8B79-37D633B846F1}">
-                <asvg:svgBlip xmlns:asvg="http://schemas.microsoft.com/office/drawing/2016/SVG/main" r:embed="rId4"/>
+                <asvg:svgBlip xmlns:asvg="http://schemas.microsoft.com/office/drawing/2016/SVG/main" r:embed="rId3"/>
               </a:ext>
             </a:extLst>
           </a:blip>
@@ -29434,7 +29434,7 @@
           <p:nvPr/>
         </p:nvPicPr>
         <p:blipFill>
-          <a:blip r:embed="rId5"/>
+          <a:blip r:embed="rId4"/>
           <a:stretch>
             <a:fillRect/>
           </a:stretch>
@@ -29494,10 +29494,10 @@
           <p:nvPr/>
         </p:nvPicPr>
         <p:blipFill>
-          <a:blip r:embed="rId3">
+          <a:blip>
             <a:extLst>
               <a:ext uri="{96DAC541-7B7A-43D3-8B79-37D633B846F1}">
-                <asvg:svgBlip xmlns:asvg="http://schemas.microsoft.com/office/drawing/2016/SVG/main" r:embed="rId4"/>
+                <asvg:svgBlip xmlns:asvg="http://schemas.microsoft.com/office/drawing/2016/SVG/main" r:embed="rId3"/>
               </a:ext>
             </a:extLst>
           </a:blip>
@@ -32270,7 +32270,7 @@
         </p:nvSpPr>
         <p:spPr>
           <a:xfrm>
-            <a:off x="4992049" y="2479723"/>
+            <a:off x="5014311" y="2479723"/>
             <a:ext cx="2498701" cy="1240764"/>
           </a:xfrm>
           <a:prstGeom prst="rect">
@@ -33096,7 +33096,7 @@
         </p:nvSpPr>
         <p:spPr>
           <a:xfrm>
-            <a:off x="5378860" y="2412411"/>
+            <a:off x="5359507" y="2412410"/>
             <a:ext cx="1899761" cy="908729"/>
           </a:xfrm>
           <a:prstGeom prst="rect">
@@ -34051,7 +34051,7 @@
         </p:nvSpPr>
         <p:spPr>
           <a:xfrm>
-            <a:off x="5378860" y="2412411"/>
+            <a:off x="5360553" y="2410951"/>
             <a:ext cx="1899761" cy="908729"/>
           </a:xfrm>
           <a:prstGeom prst="rect">
@@ -34121,7 +34121,7 @@
         </p:nvSpPr>
         <p:spPr>
           <a:xfrm>
-            <a:off x="5360555" y="3484162"/>
+            <a:off x="5360553" y="3484162"/>
             <a:ext cx="1899761" cy="908729"/>
           </a:xfrm>
           <a:prstGeom prst="rect">
@@ -35198,7 +35198,7 @@
         </p:nvSpPr>
         <p:spPr>
           <a:xfrm>
-            <a:off x="5378860" y="2412411"/>
+            <a:off x="5360551" y="2410951"/>
             <a:ext cx="1899761" cy="908729"/>
           </a:xfrm>
           <a:prstGeom prst="rect">
@@ -35268,7 +35268,7 @@
         </p:nvSpPr>
         <p:spPr>
           <a:xfrm>
-            <a:off x="5360555" y="3484162"/>
+            <a:off x="5360553" y="3484161"/>
             <a:ext cx="1899761" cy="908729"/>
           </a:xfrm>
           <a:prstGeom prst="rect">

</xml_diff>